<commit_message>
Extend Bayesian shrinkage to additional stats
</commit_message>
<xml_diff>
--- a/NBA_Optimizer_Presentation.pptx
+++ b/NBA_Optimizer_Presentation.pptx
@@ -5,27 +5,27 @@
     <p:sldMasterId id="2147483648" r:id="rId1"/>
   </p:sldMasterIdLst>
   <p:sldIdLst>
-    <p:sldId id="256" r:id="rId7"/>
-    <p:sldId id="257" r:id="rId8"/>
-    <p:sldId id="258" r:id="rId9"/>
-    <p:sldId id="259" r:id="rId10"/>
-    <p:sldId id="260" r:id="rId11"/>
-    <p:sldId id="261" r:id="rId12"/>
-    <p:sldId id="262" r:id="rId13"/>
-    <p:sldId id="263" r:id="rId14"/>
-    <p:sldId id="264" r:id="rId15"/>
-    <p:sldId id="265" r:id="rId16"/>
-    <p:sldId id="266" r:id="rId17"/>
-    <p:sldId id="267" r:id="rId18"/>
-    <p:sldId id="268" r:id="rId19"/>
-    <p:sldId id="269" r:id="rId20"/>
-    <p:sldId id="270" r:id="rId21"/>
-    <p:sldId id="271" r:id="rId22"/>
-    <p:sldId id="272" r:id="rId23"/>
-    <p:sldId id="273" r:id="rId24"/>
-    <p:sldId id="274" r:id="rId25"/>
+    <p:sldId id="256" r:id="rId2"/>
+    <p:sldId id="257" r:id="rId3"/>
+    <p:sldId id="258" r:id="rId4"/>
+    <p:sldId id="259" r:id="rId5"/>
+    <p:sldId id="260" r:id="rId6"/>
+    <p:sldId id="261" r:id="rId7"/>
+    <p:sldId id="262" r:id="rId8"/>
+    <p:sldId id="263" r:id="rId9"/>
+    <p:sldId id="264" r:id="rId10"/>
+    <p:sldId id="265" r:id="rId11"/>
+    <p:sldId id="266" r:id="rId12"/>
+    <p:sldId id="267" r:id="rId13"/>
+    <p:sldId id="268" r:id="rId14"/>
+    <p:sldId id="269" r:id="rId15"/>
+    <p:sldId id="270" r:id="rId16"/>
+    <p:sldId id="271" r:id="rId17"/>
+    <p:sldId id="272" r:id="rId18"/>
+    <p:sldId id="273" r:id="rId19"/>
+    <p:sldId id="274" r:id="rId20"/>
   </p:sldIdLst>
-  <p:sldSz cx="12191695" cy="6858000" type="screen4x3"/>
+  <p:sldSz cx="12192000" cy="6858000"/>
   <p:notesSz cx="6858000" cy="9144000"/>
   <p:defaultTextStyle>
     <a:defPPr>
@@ -122,7 +122,60 @@
       </a:defRPr>
     </a:lvl9pPr>
   </p:defaultTextStyle>
+  <p:extLst>
+    <p:ext uri="{EFAFB233-063F-42B5-8137-9DF3F51BA10A}">
+      <p15:sldGuideLst xmlns:p15="http://schemas.microsoft.com/office/powerpoint/2012/main">
+        <p15:guide id="1" orient="horz" pos="2160">
+          <p15:clr>
+            <a:srgbClr val="A4A3A4"/>
+          </p15:clr>
+        </p15:guide>
+        <p15:guide id="2" pos="2880">
+          <p15:clr>
+            <a:srgbClr val="A4A3A4"/>
+          </p15:clr>
+        </p15:guide>
+      </p15:sldGuideLst>
+    </p:ext>
+  </p:extLst>
 </p:presentation>
+</file>
+
+<file path=ppt/changesInfos/changesInfo1.xml><?xml version="1.0" encoding="utf-8"?>
+<pc:chgInfo xmlns:a="http://schemas.openxmlformats.org/drawingml/2006/main" xmlns:r="http://schemas.openxmlformats.org/officeDocument/2006/relationships" xmlns:ac="http://schemas.microsoft.com/office/drawing/2013/main/command" xmlns:pc="http://schemas.microsoft.com/office/powerpoint/2013/main/command">
+  <pc:docChgLst>
+    <pc:chgData name="Minho Moon" userId="b71dfef719442e0e" providerId="LiveId" clId="{8CD990A9-8A41-4B79-A2F7-DBE3003A1085}"/>
+    <pc:docChg chg="modSld">
+      <pc:chgData name="Minho Moon" userId="b71dfef719442e0e" providerId="LiveId" clId="{8CD990A9-8A41-4B79-A2F7-DBE3003A1085}" dt="2026-06-01T22:30:21.554" v="6" actId="14100"/>
+      <pc:docMkLst>
+        <pc:docMk/>
+      </pc:docMkLst>
+      <pc:sldChg chg="modSp mod">
+        <pc:chgData name="Minho Moon" userId="b71dfef719442e0e" providerId="LiveId" clId="{8CD990A9-8A41-4B79-A2F7-DBE3003A1085}" dt="2026-06-01T22:30:21.554" v="6" actId="14100"/>
+        <pc:sldMkLst>
+          <pc:docMk/>
+          <pc:sldMk cId="0" sldId="264"/>
+        </pc:sldMkLst>
+        <pc:picChg chg="mod">
+          <ac:chgData name="Minho Moon" userId="b71dfef719442e0e" providerId="LiveId" clId="{8CD990A9-8A41-4B79-A2F7-DBE3003A1085}" dt="2026-06-01T22:30:21.554" v="6" actId="14100"/>
+          <ac:picMkLst>
+            <pc:docMk/>
+            <pc:sldMk cId="0" sldId="264"/>
+            <ac:picMk id="4" creationId="{00000000-0000-0000-0000-000000000000}"/>
+          </ac:picMkLst>
+        </pc:picChg>
+        <pc:picChg chg="mod">
+          <ac:chgData name="Minho Moon" userId="b71dfef719442e0e" providerId="LiveId" clId="{8CD990A9-8A41-4B79-A2F7-DBE3003A1085}" dt="2026-06-01T22:30:15.524" v="4" actId="14100"/>
+          <ac:picMkLst>
+            <pc:docMk/>
+            <pc:sldMk cId="0" sldId="264"/>
+            <ac:picMk id="5" creationId="{00000000-0000-0000-0000-000000000000}"/>
+          </ac:picMkLst>
+        </pc:picChg>
+      </pc:sldChg>
+    </pc:docChg>
+  </pc:docChgLst>
+</pc:chgInfo>
 </file>
 
 <file path=ppt/slideLayouts/slideLayout1.xml><?xml version="1.0" encoding="utf-8"?>
@@ -163,10 +216,9 @@
           <a:lstStyle/>
           <a:p>
             <a:r>
-              <a:rPr lang="en-US" smtClean="0"/>
+              <a:rPr lang="en-US"/>
               <a:t>Click to edit Master title style</a:t>
             </a:r>
-            <a:endParaRPr lang="en-US"/>
           </a:p>
         </p:txBody>
       </p:sp>
@@ -282,10 +334,9 @@
           </a:lstStyle>
           <a:p>
             <a:r>
-              <a:rPr lang="en-US" smtClean="0"/>
+              <a:rPr lang="en-US"/>
               <a:t>Click to edit Master subtitle style</a:t>
             </a:r>
-            <a:endParaRPr lang="en-US"/>
           </a:p>
         </p:txBody>
       </p:sp>
@@ -306,7 +357,7 @@
           <a:p>
             <a:fld id="{5BCAD085-E8A6-8845-BD4E-CB4CCA059FC4}" type="datetimeFigureOut">
               <a:rPr lang="en-US" smtClean="0"/>
-              <a:t>1/27/13</a:t>
+              <a:t>6/1/2026</a:t>
             </a:fld>
             <a:endParaRPr lang="en-US"/>
           </a:p>
@@ -400,10 +451,9 @@
           <a:lstStyle/>
           <a:p>
             <a:r>
-              <a:rPr lang="en-US" smtClean="0"/>
+              <a:rPr lang="en-US"/>
               <a:t>Click to edit Master title style</a:t>
             </a:r>
-            <a:endParaRPr lang="en-US"/>
           </a:p>
         </p:txBody>
       </p:sp>
@@ -424,38 +474,37 @@
           <a:p>
             <a:pPr lvl="0"/>
             <a:r>
-              <a:rPr lang="en-US" smtClean="0"/>
+              <a:rPr lang="en-US"/>
               <a:t>Click to edit Master text styles</a:t>
             </a:r>
           </a:p>
           <a:p>
             <a:pPr lvl="1"/>
             <a:r>
-              <a:rPr lang="en-US" smtClean="0"/>
+              <a:rPr lang="en-US"/>
               <a:t>Second level</a:t>
             </a:r>
           </a:p>
           <a:p>
             <a:pPr lvl="2"/>
             <a:r>
-              <a:rPr lang="en-US" smtClean="0"/>
+              <a:rPr lang="en-US"/>
               <a:t>Third level</a:t>
             </a:r>
           </a:p>
           <a:p>
             <a:pPr lvl="3"/>
             <a:r>
-              <a:rPr lang="en-US" smtClean="0"/>
+              <a:rPr lang="en-US"/>
               <a:t>Fourth level</a:t>
             </a:r>
           </a:p>
           <a:p>
             <a:pPr lvl="4"/>
             <a:r>
-              <a:rPr lang="en-US" smtClean="0"/>
+              <a:rPr lang="en-US"/>
               <a:t>Fifth level</a:t>
             </a:r>
-            <a:endParaRPr lang="en-US"/>
           </a:p>
         </p:txBody>
       </p:sp>
@@ -476,7 +525,7 @@
           <a:p>
             <a:fld id="{5BCAD085-E8A6-8845-BD4E-CB4CCA059FC4}" type="datetimeFigureOut">
               <a:rPr lang="en-US" smtClean="0"/>
-              <a:t>1/27/13</a:t>
+              <a:t>6/1/2026</a:t>
             </a:fld>
             <a:endParaRPr lang="en-US"/>
           </a:p>
@@ -575,10 +624,9 @@
           <a:lstStyle/>
           <a:p>
             <a:r>
-              <a:rPr lang="en-US" smtClean="0"/>
+              <a:rPr lang="en-US"/>
               <a:t>Click to edit Master title style</a:t>
             </a:r>
-            <a:endParaRPr lang="en-US"/>
           </a:p>
         </p:txBody>
       </p:sp>
@@ -604,38 +652,37 @@
           <a:p>
             <a:pPr lvl="0"/>
             <a:r>
-              <a:rPr lang="en-US" smtClean="0"/>
+              <a:rPr lang="en-US"/>
               <a:t>Click to edit Master text styles</a:t>
             </a:r>
           </a:p>
           <a:p>
             <a:pPr lvl="1"/>
             <a:r>
-              <a:rPr lang="en-US" smtClean="0"/>
+              <a:rPr lang="en-US"/>
               <a:t>Second level</a:t>
             </a:r>
           </a:p>
           <a:p>
             <a:pPr lvl="2"/>
             <a:r>
-              <a:rPr lang="en-US" smtClean="0"/>
+              <a:rPr lang="en-US"/>
               <a:t>Third level</a:t>
             </a:r>
           </a:p>
           <a:p>
             <a:pPr lvl="3"/>
             <a:r>
-              <a:rPr lang="en-US" smtClean="0"/>
+              <a:rPr lang="en-US"/>
               <a:t>Fourth level</a:t>
             </a:r>
           </a:p>
           <a:p>
             <a:pPr lvl="4"/>
             <a:r>
-              <a:rPr lang="en-US" smtClean="0"/>
+              <a:rPr lang="en-US"/>
               <a:t>Fifth level</a:t>
             </a:r>
-            <a:endParaRPr lang="en-US"/>
           </a:p>
         </p:txBody>
       </p:sp>
@@ -656,7 +703,7 @@
           <a:p>
             <a:fld id="{5BCAD085-E8A6-8845-BD4E-CB4CCA059FC4}" type="datetimeFigureOut">
               <a:rPr lang="en-US" smtClean="0"/>
-              <a:t>1/27/13</a:t>
+              <a:t>6/1/2026</a:t>
             </a:fld>
             <a:endParaRPr lang="en-US"/>
           </a:p>
@@ -750,10 +797,9 @@
           <a:lstStyle/>
           <a:p>
             <a:r>
-              <a:rPr lang="en-US" smtClean="0"/>
+              <a:rPr lang="en-US"/>
               <a:t>Click to edit Master title style</a:t>
             </a:r>
-            <a:endParaRPr lang="en-US"/>
           </a:p>
         </p:txBody>
       </p:sp>
@@ -774,38 +820,37 @@
           <a:p>
             <a:pPr lvl="0"/>
             <a:r>
-              <a:rPr lang="en-US" smtClean="0"/>
+              <a:rPr lang="en-US"/>
               <a:t>Click to edit Master text styles</a:t>
             </a:r>
           </a:p>
           <a:p>
             <a:pPr lvl="1"/>
             <a:r>
-              <a:rPr lang="en-US" smtClean="0"/>
+              <a:rPr lang="en-US"/>
               <a:t>Second level</a:t>
             </a:r>
           </a:p>
           <a:p>
             <a:pPr lvl="2"/>
             <a:r>
-              <a:rPr lang="en-US" smtClean="0"/>
+              <a:rPr lang="en-US"/>
               <a:t>Third level</a:t>
             </a:r>
           </a:p>
           <a:p>
             <a:pPr lvl="3"/>
             <a:r>
-              <a:rPr lang="en-US" smtClean="0"/>
+              <a:rPr lang="en-US"/>
               <a:t>Fourth level</a:t>
             </a:r>
           </a:p>
           <a:p>
             <a:pPr lvl="4"/>
             <a:r>
-              <a:rPr lang="en-US" smtClean="0"/>
+              <a:rPr lang="en-US"/>
               <a:t>Fifth level</a:t>
             </a:r>
-            <a:endParaRPr lang="en-US"/>
           </a:p>
         </p:txBody>
       </p:sp>
@@ -826,7 +871,7 @@
           <a:p>
             <a:fld id="{5BCAD085-E8A6-8845-BD4E-CB4CCA059FC4}" type="datetimeFigureOut">
               <a:rPr lang="en-US" smtClean="0"/>
-              <a:t>1/27/13</a:t>
+              <a:t>6/1/2026</a:t>
             </a:fld>
             <a:endParaRPr lang="en-US"/>
           </a:p>
@@ -929,10 +974,9 @@
           </a:lstStyle>
           <a:p>
             <a:r>
-              <a:rPr lang="en-US" smtClean="0"/>
+              <a:rPr lang="en-US"/>
               <a:t>Click to edit Master title style</a:t>
             </a:r>
-            <a:endParaRPr lang="en-US"/>
           </a:p>
         </p:txBody>
       </p:sp>
@@ -1049,7 +1093,7 @@
           <a:p>
             <a:pPr lvl="0"/>
             <a:r>
-              <a:rPr lang="en-US" smtClean="0"/>
+              <a:rPr lang="en-US"/>
               <a:t>Click to edit Master text styles</a:t>
             </a:r>
           </a:p>
@@ -1072,7 +1116,7 @@
           <a:p>
             <a:fld id="{5BCAD085-E8A6-8845-BD4E-CB4CCA059FC4}" type="datetimeFigureOut">
               <a:rPr lang="en-US" smtClean="0"/>
-              <a:t>1/27/13</a:t>
+              <a:t>6/1/2026</a:t>
             </a:fld>
             <a:endParaRPr lang="en-US"/>
           </a:p>
@@ -1166,10 +1210,9 @@
           <a:lstStyle/>
           <a:p>
             <a:r>
-              <a:rPr lang="en-US" smtClean="0"/>
+              <a:rPr lang="en-US"/>
               <a:t>Click to edit Master title style</a:t>
             </a:r>
-            <a:endParaRPr lang="en-US"/>
           </a:p>
         </p:txBody>
       </p:sp>
@@ -1223,38 +1266,37 @@
           <a:p>
             <a:pPr lvl="0"/>
             <a:r>
-              <a:rPr lang="en-US" smtClean="0"/>
+              <a:rPr lang="en-US"/>
               <a:t>Click to edit Master text styles</a:t>
             </a:r>
           </a:p>
           <a:p>
             <a:pPr lvl="1"/>
             <a:r>
-              <a:rPr lang="en-US" smtClean="0"/>
+              <a:rPr lang="en-US"/>
               <a:t>Second level</a:t>
             </a:r>
           </a:p>
           <a:p>
             <a:pPr lvl="2"/>
             <a:r>
-              <a:rPr lang="en-US" smtClean="0"/>
+              <a:rPr lang="en-US"/>
               <a:t>Third level</a:t>
             </a:r>
           </a:p>
           <a:p>
             <a:pPr lvl="3"/>
             <a:r>
-              <a:rPr lang="en-US" smtClean="0"/>
+              <a:rPr lang="en-US"/>
               <a:t>Fourth level</a:t>
             </a:r>
           </a:p>
           <a:p>
             <a:pPr lvl="4"/>
             <a:r>
-              <a:rPr lang="en-US" smtClean="0"/>
+              <a:rPr lang="en-US"/>
               <a:t>Fifth level</a:t>
             </a:r>
-            <a:endParaRPr lang="en-US"/>
           </a:p>
         </p:txBody>
       </p:sp>
@@ -1308,38 +1350,37 @@
           <a:p>
             <a:pPr lvl="0"/>
             <a:r>
-              <a:rPr lang="en-US" smtClean="0"/>
+              <a:rPr lang="en-US"/>
               <a:t>Click to edit Master text styles</a:t>
             </a:r>
           </a:p>
           <a:p>
             <a:pPr lvl="1"/>
             <a:r>
-              <a:rPr lang="en-US" smtClean="0"/>
+              <a:rPr lang="en-US"/>
               <a:t>Second level</a:t>
             </a:r>
           </a:p>
           <a:p>
             <a:pPr lvl="2"/>
             <a:r>
-              <a:rPr lang="en-US" smtClean="0"/>
+              <a:rPr lang="en-US"/>
               <a:t>Third level</a:t>
             </a:r>
           </a:p>
           <a:p>
             <a:pPr lvl="3"/>
             <a:r>
-              <a:rPr lang="en-US" smtClean="0"/>
+              <a:rPr lang="en-US"/>
               <a:t>Fourth level</a:t>
             </a:r>
           </a:p>
           <a:p>
             <a:pPr lvl="4"/>
             <a:r>
-              <a:rPr lang="en-US" smtClean="0"/>
+              <a:rPr lang="en-US"/>
               <a:t>Fifth level</a:t>
             </a:r>
-            <a:endParaRPr lang="en-US"/>
           </a:p>
         </p:txBody>
       </p:sp>
@@ -1360,7 +1401,7 @@
           <a:p>
             <a:fld id="{5BCAD085-E8A6-8845-BD4E-CB4CCA059FC4}" type="datetimeFigureOut">
               <a:rPr lang="en-US" smtClean="0"/>
-              <a:t>1/27/13</a:t>
+              <a:t>6/1/2026</a:t>
             </a:fld>
             <a:endParaRPr lang="en-US"/>
           </a:p>
@@ -1458,10 +1499,9 @@
           </a:lstStyle>
           <a:p>
             <a:r>
-              <a:rPr lang="en-US" smtClean="0"/>
+              <a:rPr lang="en-US"/>
               <a:t>Click to edit Master title style</a:t>
             </a:r>
-            <a:endParaRPr lang="en-US"/>
           </a:p>
         </p:txBody>
       </p:sp>
@@ -1524,7 +1564,7 @@
           <a:p>
             <a:pPr lvl="0"/>
             <a:r>
-              <a:rPr lang="en-US" smtClean="0"/>
+              <a:rPr lang="en-US"/>
               <a:t>Click to edit Master text styles</a:t>
             </a:r>
           </a:p>
@@ -1580,38 +1620,37 @@
           <a:p>
             <a:pPr lvl="0"/>
             <a:r>
-              <a:rPr lang="en-US" smtClean="0"/>
+              <a:rPr lang="en-US"/>
               <a:t>Click to edit Master text styles</a:t>
             </a:r>
           </a:p>
           <a:p>
             <a:pPr lvl="1"/>
             <a:r>
-              <a:rPr lang="en-US" smtClean="0"/>
+              <a:rPr lang="en-US"/>
               <a:t>Second level</a:t>
             </a:r>
           </a:p>
           <a:p>
             <a:pPr lvl="2"/>
             <a:r>
-              <a:rPr lang="en-US" smtClean="0"/>
+              <a:rPr lang="en-US"/>
               <a:t>Third level</a:t>
             </a:r>
           </a:p>
           <a:p>
             <a:pPr lvl="3"/>
             <a:r>
-              <a:rPr lang="en-US" smtClean="0"/>
+              <a:rPr lang="en-US"/>
               <a:t>Fourth level</a:t>
             </a:r>
           </a:p>
           <a:p>
             <a:pPr lvl="4"/>
             <a:r>
-              <a:rPr lang="en-US" smtClean="0"/>
+              <a:rPr lang="en-US"/>
               <a:t>Fifth level</a:t>
             </a:r>
-            <a:endParaRPr lang="en-US"/>
           </a:p>
         </p:txBody>
       </p:sp>
@@ -1674,7 +1713,7 @@
           <a:p>
             <a:pPr lvl="0"/>
             <a:r>
-              <a:rPr lang="en-US" smtClean="0"/>
+              <a:rPr lang="en-US"/>
               <a:t>Click to edit Master text styles</a:t>
             </a:r>
           </a:p>
@@ -1730,38 +1769,37 @@
           <a:p>
             <a:pPr lvl="0"/>
             <a:r>
-              <a:rPr lang="en-US" smtClean="0"/>
+              <a:rPr lang="en-US"/>
               <a:t>Click to edit Master text styles</a:t>
             </a:r>
           </a:p>
           <a:p>
             <a:pPr lvl="1"/>
             <a:r>
-              <a:rPr lang="en-US" smtClean="0"/>
+              <a:rPr lang="en-US"/>
               <a:t>Second level</a:t>
             </a:r>
           </a:p>
           <a:p>
             <a:pPr lvl="2"/>
             <a:r>
-              <a:rPr lang="en-US" smtClean="0"/>
+              <a:rPr lang="en-US"/>
               <a:t>Third level</a:t>
             </a:r>
           </a:p>
           <a:p>
             <a:pPr lvl="3"/>
             <a:r>
-              <a:rPr lang="en-US" smtClean="0"/>
+              <a:rPr lang="en-US"/>
               <a:t>Fourth level</a:t>
             </a:r>
           </a:p>
           <a:p>
             <a:pPr lvl="4"/>
             <a:r>
-              <a:rPr lang="en-US" smtClean="0"/>
+              <a:rPr lang="en-US"/>
               <a:t>Fifth level</a:t>
             </a:r>
-            <a:endParaRPr lang="en-US"/>
           </a:p>
         </p:txBody>
       </p:sp>
@@ -1782,7 +1820,7 @@
           <a:p>
             <a:fld id="{5BCAD085-E8A6-8845-BD4E-CB4CCA059FC4}" type="datetimeFigureOut">
               <a:rPr lang="en-US" smtClean="0"/>
-              <a:t>1/27/13</a:t>
+              <a:t>6/1/2026</a:t>
             </a:fld>
             <a:endParaRPr lang="en-US"/>
           </a:p>
@@ -1876,10 +1914,9 @@
           <a:lstStyle/>
           <a:p>
             <a:r>
-              <a:rPr lang="en-US" smtClean="0"/>
+              <a:rPr lang="en-US"/>
               <a:t>Click to edit Master title style</a:t>
             </a:r>
-            <a:endParaRPr lang="en-US"/>
           </a:p>
         </p:txBody>
       </p:sp>
@@ -1900,7 +1937,7 @@
           <a:p>
             <a:fld id="{5BCAD085-E8A6-8845-BD4E-CB4CCA059FC4}" type="datetimeFigureOut">
               <a:rPr lang="en-US" smtClean="0"/>
-              <a:t>1/27/13</a:t>
+              <a:t>6/1/2026</a:t>
             </a:fld>
             <a:endParaRPr lang="en-US"/>
           </a:p>
@@ -1995,7 +2032,7 @@
           <a:p>
             <a:fld id="{5BCAD085-E8A6-8845-BD4E-CB4CCA059FC4}" type="datetimeFigureOut">
               <a:rPr lang="en-US" smtClean="0"/>
-              <a:t>1/27/13</a:t>
+              <a:t>6/1/2026</a:t>
             </a:fld>
             <a:endParaRPr lang="en-US"/>
           </a:p>
@@ -2098,10 +2135,9 @@
           </a:lstStyle>
           <a:p>
             <a:r>
-              <a:rPr lang="en-US" smtClean="0"/>
+              <a:rPr lang="en-US"/>
               <a:t>Click to edit Master title style</a:t>
             </a:r>
-            <a:endParaRPr lang="en-US"/>
           </a:p>
         </p:txBody>
       </p:sp>
@@ -2155,38 +2191,37 @@
           <a:p>
             <a:pPr lvl="0"/>
             <a:r>
-              <a:rPr lang="en-US" smtClean="0"/>
+              <a:rPr lang="en-US"/>
               <a:t>Click to edit Master text styles</a:t>
             </a:r>
           </a:p>
           <a:p>
             <a:pPr lvl="1"/>
             <a:r>
-              <a:rPr lang="en-US" smtClean="0"/>
+              <a:rPr lang="en-US"/>
               <a:t>Second level</a:t>
             </a:r>
           </a:p>
           <a:p>
             <a:pPr lvl="2"/>
             <a:r>
-              <a:rPr lang="en-US" smtClean="0"/>
+              <a:rPr lang="en-US"/>
               <a:t>Third level</a:t>
             </a:r>
           </a:p>
           <a:p>
             <a:pPr lvl="3"/>
             <a:r>
-              <a:rPr lang="en-US" smtClean="0"/>
+              <a:rPr lang="en-US"/>
               <a:t>Fourth level</a:t>
             </a:r>
           </a:p>
           <a:p>
             <a:pPr lvl="4"/>
             <a:r>
-              <a:rPr lang="en-US" smtClean="0"/>
+              <a:rPr lang="en-US"/>
               <a:t>Fifth level</a:t>
             </a:r>
-            <a:endParaRPr lang="en-US"/>
           </a:p>
         </p:txBody>
       </p:sp>
@@ -2249,7 +2284,7 @@
           <a:p>
             <a:pPr lvl="0"/>
             <a:r>
-              <a:rPr lang="en-US" smtClean="0"/>
+              <a:rPr lang="en-US"/>
               <a:t>Click to edit Master text styles</a:t>
             </a:r>
           </a:p>
@@ -2272,7 +2307,7 @@
           <a:p>
             <a:fld id="{5BCAD085-E8A6-8845-BD4E-CB4CCA059FC4}" type="datetimeFigureOut">
               <a:rPr lang="en-US" smtClean="0"/>
-              <a:t>1/27/13</a:t>
+              <a:t>6/1/2026</a:t>
             </a:fld>
             <a:endParaRPr lang="en-US"/>
           </a:p>
@@ -2375,10 +2410,9 @@
           </a:lstStyle>
           <a:p>
             <a:r>
-              <a:rPr lang="en-US" smtClean="0"/>
+              <a:rPr lang="en-US"/>
               <a:t>Click to edit Master title style</a:t>
             </a:r>
-            <a:endParaRPr lang="en-US"/>
           </a:p>
         </p:txBody>
       </p:sp>
@@ -2502,7 +2536,7 @@
           <a:p>
             <a:pPr lvl="0"/>
             <a:r>
-              <a:rPr lang="en-US" smtClean="0"/>
+              <a:rPr lang="en-US"/>
               <a:t>Click to edit Master text styles</a:t>
             </a:r>
           </a:p>
@@ -2525,7 +2559,7 @@
           <a:p>
             <a:fld id="{5BCAD085-E8A6-8845-BD4E-CB4CCA059FC4}" type="datetimeFigureOut">
               <a:rPr lang="en-US" smtClean="0"/>
-              <a:t>1/27/13</a:t>
+              <a:t>6/1/2026</a:t>
             </a:fld>
             <a:endParaRPr lang="en-US"/>
           </a:p>
@@ -2634,10 +2668,9 @@
           <a:lstStyle/>
           <a:p>
             <a:r>
-              <a:rPr lang="en-US" smtClean="0"/>
+              <a:rPr lang="en-US"/>
               <a:t>Click to edit Master title style</a:t>
             </a:r>
-            <a:endParaRPr lang="en-US"/>
           </a:p>
         </p:txBody>
       </p:sp>
@@ -2668,38 +2701,37 @@
           <a:p>
             <a:pPr lvl="0"/>
             <a:r>
-              <a:rPr lang="en-US" smtClean="0"/>
+              <a:rPr lang="en-US"/>
               <a:t>Click to edit Master text styles</a:t>
             </a:r>
           </a:p>
           <a:p>
             <a:pPr lvl="1"/>
             <a:r>
-              <a:rPr lang="en-US" smtClean="0"/>
+              <a:rPr lang="en-US"/>
               <a:t>Second level</a:t>
             </a:r>
           </a:p>
           <a:p>
             <a:pPr lvl="2"/>
             <a:r>
-              <a:rPr lang="en-US" smtClean="0"/>
+              <a:rPr lang="en-US"/>
               <a:t>Third level</a:t>
             </a:r>
           </a:p>
           <a:p>
             <a:pPr lvl="3"/>
             <a:r>
-              <a:rPr lang="en-US" smtClean="0"/>
+              <a:rPr lang="en-US"/>
               <a:t>Fourth level</a:t>
             </a:r>
           </a:p>
           <a:p>
             <a:pPr lvl="4"/>
             <a:r>
-              <a:rPr lang="en-US" smtClean="0"/>
+              <a:rPr lang="en-US"/>
               <a:t>Fifth level</a:t>
             </a:r>
-            <a:endParaRPr lang="en-US"/>
           </a:p>
         </p:txBody>
       </p:sp>
@@ -2738,7 +2770,7 @@
           <a:p>
             <a:fld id="{5BCAD085-E8A6-8845-BD4E-CB4CCA059FC4}" type="datetimeFigureOut">
               <a:rPr lang="en-US" smtClean="0"/>
-              <a:t>1/27/13</a:t>
+              <a:t>6/1/2026</a:t>
             </a:fld>
             <a:endParaRPr lang="en-US"/>
           </a:p>
@@ -3097,7 +3129,7 @@
 </file>
 
 <file path=ppt/slides/slide1.xml><?xml version="1.0" encoding="utf-8"?>
-<p:sld xmlns:a="http://schemas.openxmlformats.org/drawingml/2006/main" xmlns:p="http://schemas.openxmlformats.org/presentationml/2006/main" xmlns:r="http://schemas.openxmlformats.org/officeDocument/2006/relationships">
+<p:sld xmlns:a="http://schemas.openxmlformats.org/drawingml/2006/main" xmlns:r="http://schemas.openxmlformats.org/officeDocument/2006/relationships" xmlns:p="http://schemas.openxmlformats.org/presentationml/2006/main">
   <p:cSld>
     <p:bg>
       <p:bgPr>
@@ -3113,7 +3145,14 @@
         <p:cNvGrpSpPr/>
         <p:nvPr/>
       </p:nvGrpSpPr>
-      <p:grpSpPr/>
+      <p:grpSpPr>
+        <a:xfrm>
+          <a:off x="0" y="0"/>
+          <a:ext cx="0" cy="0"/>
+          <a:chOff x="0" y="0"/>
+          <a:chExt cx="0" cy="0"/>
+        </a:xfrm>
+      </p:grpSpPr>
       <p:sp>
         <p:nvSpPr>
           <p:cNvPr id="2" name="TextBox 1"/>
@@ -3267,7 +3306,7 @@
 </file>
 
 <file path=ppt/slides/slide10.xml><?xml version="1.0" encoding="utf-8"?>
-<p:sld xmlns:a="http://schemas.openxmlformats.org/drawingml/2006/main" xmlns:p="http://schemas.openxmlformats.org/presentationml/2006/main" xmlns:r="http://schemas.openxmlformats.org/officeDocument/2006/relationships">
+<p:sld xmlns:a="http://schemas.openxmlformats.org/drawingml/2006/main" xmlns:r="http://schemas.openxmlformats.org/officeDocument/2006/relationships" xmlns:p="http://schemas.openxmlformats.org/presentationml/2006/main">
   <p:cSld>
     <p:bg>
       <p:bgPr>
@@ -3283,7 +3322,14 @@
         <p:cNvGrpSpPr/>
         <p:nvPr/>
       </p:nvGrpSpPr>
-      <p:grpSpPr/>
+      <p:grpSpPr>
+        <a:xfrm>
+          <a:off x="0" y="0"/>
+          <a:ext cx="0" cy="0"/>
+          <a:chOff x="0" y="0"/>
+          <a:chExt cx="0" cy="0"/>
+        </a:xfrm>
+      </p:grpSpPr>
       <p:sp>
         <p:nvSpPr>
           <p:cNvPr id="2" name="TextBox 1"/>
@@ -3389,7 +3435,7 @@
 </file>
 
 <file path=ppt/slides/slide11.xml><?xml version="1.0" encoding="utf-8"?>
-<p:sld xmlns:a="http://schemas.openxmlformats.org/drawingml/2006/main" xmlns:p="http://schemas.openxmlformats.org/presentationml/2006/main" xmlns:r="http://schemas.openxmlformats.org/officeDocument/2006/relationships">
+<p:sld xmlns:a="http://schemas.openxmlformats.org/drawingml/2006/main" xmlns:r="http://schemas.openxmlformats.org/officeDocument/2006/relationships" xmlns:p="http://schemas.openxmlformats.org/presentationml/2006/main">
   <p:cSld>
     <p:bg>
       <p:bgPr>
@@ -3405,7 +3451,14 @@
         <p:cNvGrpSpPr/>
         <p:nvPr/>
       </p:nvGrpSpPr>
-      <p:grpSpPr/>
+      <p:grpSpPr>
+        <a:xfrm>
+          <a:off x="0" y="0"/>
+          <a:ext cx="0" cy="0"/>
+          <a:chOff x="0" y="0"/>
+          <a:chExt cx="0" cy="0"/>
+        </a:xfrm>
+      </p:grpSpPr>
       <p:sp>
         <p:nvSpPr>
           <p:cNvPr id="2" name="TextBox 1"/>
@@ -3523,6 +3576,7 @@
                 <a:latin typeface="Calibri"/>
               </a:defRPr>
             </a:pPr>
+            <a:endParaRPr/>
           </a:p>
           <a:p>
             <a:pPr>
@@ -3632,6 +3686,7 @@
                 <a:latin typeface="Calibri"/>
               </a:defRPr>
             </a:pPr>
+            <a:endParaRPr/>
           </a:p>
           <a:p>
             <a:pPr>
@@ -3724,7 +3779,7 @@
 </file>
 
 <file path=ppt/slides/slide12.xml><?xml version="1.0" encoding="utf-8"?>
-<p:sld xmlns:a="http://schemas.openxmlformats.org/drawingml/2006/main" xmlns:p="http://schemas.openxmlformats.org/presentationml/2006/main" xmlns:r="http://schemas.openxmlformats.org/officeDocument/2006/relationships">
+<p:sld xmlns:a="http://schemas.openxmlformats.org/drawingml/2006/main" xmlns:r="http://schemas.openxmlformats.org/officeDocument/2006/relationships" xmlns:p="http://schemas.openxmlformats.org/presentationml/2006/main">
   <p:cSld>
     <p:bg>
       <p:bgPr>
@@ -3740,7 +3795,14 @@
         <p:cNvGrpSpPr/>
         <p:nvPr/>
       </p:nvGrpSpPr>
-      <p:grpSpPr/>
+      <p:grpSpPr>
+        <a:xfrm>
+          <a:off x="0" y="0"/>
+          <a:ext cx="0" cy="0"/>
+          <a:chOff x="0" y="0"/>
+          <a:chExt cx="0" cy="0"/>
+        </a:xfrm>
+      </p:grpSpPr>
       <p:sp>
         <p:nvSpPr>
           <p:cNvPr id="2" name="TextBox 1"/>
@@ -3842,6 +3904,7 @@
                 <a:latin typeface="Calibri"/>
               </a:defRPr>
             </a:pPr>
+            <a:endParaRPr/>
           </a:p>
           <a:p>
             <a:pPr>
@@ -3871,6 +3934,7 @@
                 <a:latin typeface="Calibri"/>
               </a:defRPr>
             </a:pPr>
+            <a:endParaRPr/>
           </a:p>
           <a:p>
             <a:pPr>
@@ -3916,6 +3980,7 @@
                 <a:latin typeface="Calibri"/>
               </a:defRPr>
             </a:pPr>
+            <a:endParaRPr/>
           </a:p>
           <a:p>
             <a:pPr>
@@ -3961,6 +4026,7 @@
                 <a:latin typeface="Calibri"/>
               </a:defRPr>
             </a:pPr>
+            <a:endParaRPr/>
           </a:p>
           <a:p>
             <a:pPr>
@@ -4006,6 +4072,7 @@
                 <a:latin typeface="Calibri"/>
               </a:defRPr>
             </a:pPr>
+            <a:endParaRPr/>
           </a:p>
           <a:p>
             <a:pPr>
@@ -4050,7 +4117,7 @@
 </file>
 
 <file path=ppt/slides/slide13.xml><?xml version="1.0" encoding="utf-8"?>
-<p:sld xmlns:a="http://schemas.openxmlformats.org/drawingml/2006/main" xmlns:p="http://schemas.openxmlformats.org/presentationml/2006/main" xmlns:r="http://schemas.openxmlformats.org/officeDocument/2006/relationships">
+<p:sld xmlns:a="http://schemas.openxmlformats.org/drawingml/2006/main" xmlns:r="http://schemas.openxmlformats.org/officeDocument/2006/relationships" xmlns:p="http://schemas.openxmlformats.org/presentationml/2006/main">
   <p:cSld>
     <p:bg>
       <p:bgPr>
@@ -4066,7 +4133,14 @@
         <p:cNvGrpSpPr/>
         <p:nvPr/>
       </p:nvGrpSpPr>
-      <p:grpSpPr/>
+      <p:grpSpPr>
+        <a:xfrm>
+          <a:off x="0" y="0"/>
+          <a:ext cx="0" cy="0"/>
+          <a:chOff x="0" y="0"/>
+          <a:chExt cx="0" cy="0"/>
+        </a:xfrm>
+      </p:grpSpPr>
       <p:sp>
         <p:nvSpPr>
           <p:cNvPr id="2" name="TextBox 1"/>
@@ -4173,6 +4247,7 @@
               <a:t>Scenario J — Value / Efficiency        Maximize VORPD (Moneyball)</a:t>
             </a:r>
             <a:br/>
+            <a:endParaRPr/>
           </a:p>
         </p:txBody>
       </p:sp>
@@ -4225,7 +4300,7 @@
 </file>
 
 <file path=ppt/slides/slide14.xml><?xml version="1.0" encoding="utf-8"?>
-<p:sld xmlns:a="http://schemas.openxmlformats.org/drawingml/2006/main" xmlns:p="http://schemas.openxmlformats.org/presentationml/2006/main" xmlns:r="http://schemas.openxmlformats.org/officeDocument/2006/relationships">
+<p:sld xmlns:a="http://schemas.openxmlformats.org/drawingml/2006/main" xmlns:r="http://schemas.openxmlformats.org/officeDocument/2006/relationships" xmlns:p="http://schemas.openxmlformats.org/presentationml/2006/main">
   <p:cSld>
     <p:bg>
       <p:bgPr>
@@ -4241,7 +4316,14 @@
         <p:cNvGrpSpPr/>
         <p:nvPr/>
       </p:nvGrpSpPr>
-      <p:grpSpPr/>
+      <p:grpSpPr>
+        <a:xfrm>
+          <a:off x="0" y="0"/>
+          <a:ext cx="0" cy="0"/>
+          <a:chOff x="0" y="0"/>
+          <a:chExt cx="0" cy="0"/>
+        </a:xfrm>
+      </p:grpSpPr>
       <p:sp>
         <p:nvSpPr>
           <p:cNvPr id="2" name="TextBox 1"/>
@@ -4317,68 +4399,68 @@
             </a:r>
             <a:br/>
             <a:r>
-              <a:t> 1  Shai Gilgeous-Alexander      Elite Playmaker          91.4  $ 33,729,226</a:t>
-            </a:r>
-            <a:br/>
-            <a:r>
-              <a:t> 2  LaMelo Ball                  Elite Playmaker          84.4  $ 33,399,888</a:t>
-            </a:r>
-            <a:br/>
-            <a:r>
-              <a:t> 3  Marcus Smart                 Elite Playmaker          79.9  $ 17,528,347</a:t>
-            </a:r>
-            <a:br/>
-            <a:r>
-              <a:t> 4  De'Anthony Melton            Perimeter Scorer         68.9  $  2,710,900</a:t>
-            </a:r>
-            <a:br/>
-            <a:r>
-              <a:t> 5  Victor Wembanyama            Two-Way Big              68.7  $ 11,770,308</a:t>
-            </a:r>
-            <a:br/>
-            <a:r>
-              <a:t> 6  Tre Jones                    Defensive Wing           67.6  $  7,039,195</a:t>
-            </a:r>
-            <a:br/>
-            <a:r>
-              <a:t> 7  Dennis Smith Jr.             Defensive Wing           66.5  $  3,000,000</a:t>
-            </a:r>
-            <a:br/>
-            <a:r>
-              <a:t> 8  Tari Eason                   Defensive Wing           65.4  $  4,994,103</a:t>
-            </a:r>
-            <a:br/>
-            <a:r>
-              <a:t> 9  Scotty Pippen Jr.            Elite Playmaker          64.5  $  1,998,018</a:t>
-            </a:r>
-            <a:br/>
-            <a:r>
-              <a:t>10  Jared Butler                 Defensive Wing           64.1  $  2,019,706</a:t>
-            </a:r>
-            <a:br/>
-            <a:r>
-              <a:t>11  Russell Westbrook            Versatile Scorer         63.1  $  2,020,490</a:t>
-            </a:r>
-            <a:br/>
-            <a:r>
-              <a:t>12  Kris Dunn                    Perimeter Scorer         60.2  $  4,774,686</a:t>
-            </a:r>
-            <a:br/>
-            <a:r>
-              <a:t>13  Chris Paul                   Versatile Scorer         60.1  $  2,020,490</a:t>
-            </a:r>
-            <a:br/>
-            <a:r>
-              <a:t>14  Clint Capela                 Two-Way Big              43.1  $  5,895,326</a:t>
-            </a:r>
-            <a:br/>
-            <a:r>
-              <a:t>15  Kyle Lowry                   Bench / Role Player      41.7  $  2,020,490</a:t>
-            </a:r>
-            <a:br/>
-            <a:br/>
-            <a:r>
-              <a:t>TOTAL                                                     989.5  $134,921,173</a:t>
+              <a:t> 1  Shai Gilgeous-Alexander      Elite Playmaker          89.1  $ 33,729,226</a:t>
+            </a:r>
+            <a:br/>
+            <a:r>
+              <a:t> 2  Marcus Smart                 Elite Playmaker          70.4  $ 17,528,347</a:t>
+            </a:r>
+            <a:br/>
+            <a:r>
+              <a:t> 3  Jusuf Nurkić                 Perimeter Scorer         67.7  $ 17,048,050</a:t>
+            </a:r>
+            <a:br/>
+            <a:r>
+              <a:t> 4  Victor Wembanyama            Two-Way Big              65.6  $ 11,770,308</a:t>
+            </a:r>
+            <a:br/>
+            <a:r>
+              <a:t> 5  Tre Jones                    Defensive Wing           63.2  $  7,039,195</a:t>
+            </a:r>
+            <a:br/>
+            <a:r>
+              <a:t> 6  De'Anthony Melton            Perimeter Scorer         61.6  $  2,710,900</a:t>
+            </a:r>
+            <a:br/>
+            <a:r>
+              <a:t> 7  Bogdan Bogdanović            Perimeter Scorer         59.1  $ 14,095,988</a:t>
+            </a:r>
+            <a:br/>
+            <a:r>
+              <a:t> 8  Russell Westbrook            Versatile Scorer         58.6  $  2,020,490</a:t>
+            </a:r>
+            <a:br/>
+            <a:r>
+              <a:t> 9  Dennis Smith Jr.             Defensive Wing           58.5  $  3,000,000</a:t>
+            </a:r>
+            <a:br/>
+            <a:r>
+              <a:t>10  Alperen Sengun               Elite Playmaker          55.7  $  3,922,440</a:t>
+            </a:r>
+            <a:br/>
+            <a:r>
+              <a:t>11  Tari Eason                   Defensive Wing           54.2  $  4,994,103</a:t>
+            </a:r>
+            <a:br/>
+            <a:r>
+              <a:t>12  Scotty Pippen Jr.            Elite Playmaker          53.7  $  1,998,018</a:t>
+            </a:r>
+            <a:br/>
+            <a:r>
+              <a:t>13  Vasilije Micic               Versatile Scorer         50.0  $  2,000,000</a:t>
+            </a:r>
+            <a:br/>
+            <a:r>
+              <a:t>14  Chet Holmgren                Two-Way Big              40.2  $ 12,082,222</a:t>
+            </a:r>
+            <a:br/>
+            <a:r>
+              <a:t>15  Bones Hyland                 Bench / Role Player      33.3  $  2,020,490</a:t>
+            </a:r>
+            <a:br/>
+            <a:br/>
+            <a:r>
+              <a:t>TOTAL                                                     880.9  $135,959,777</a:t>
             </a:r>
           </a:p>
         </p:txBody>
@@ -4392,7 +4474,7 @@
 </file>
 
 <file path=ppt/slides/slide15.xml><?xml version="1.0" encoding="utf-8"?>
-<p:sld xmlns:a="http://schemas.openxmlformats.org/drawingml/2006/main" xmlns:p="http://schemas.openxmlformats.org/presentationml/2006/main" xmlns:r="http://schemas.openxmlformats.org/officeDocument/2006/relationships">
+<p:sld xmlns:a="http://schemas.openxmlformats.org/drawingml/2006/main" xmlns:r="http://schemas.openxmlformats.org/officeDocument/2006/relationships" xmlns:p="http://schemas.openxmlformats.org/presentationml/2006/main">
   <p:cSld>
     <p:bg>
       <p:bgPr>
@@ -4408,7 +4490,14 @@
         <p:cNvGrpSpPr/>
         <p:nvPr/>
       </p:nvGrpSpPr>
-      <p:grpSpPr/>
+      <p:grpSpPr>
+        <a:xfrm>
+          <a:off x="0" y="0"/>
+          <a:ext cx="0" cy="0"/>
+          <a:chOff x="0" y="0"/>
+          <a:chExt cx="0" cy="0"/>
+        </a:xfrm>
+      </p:grpSpPr>
       <p:sp>
         <p:nvSpPr>
           <p:cNvPr id="2" name="TextBox 1"/>
@@ -4479,6 +4568,7 @@
               </a:defRPr>
             </a:pPr>
             <a:r>
+              <a:rPr dirty="0"/>
               <a:t>87 salary imputation errors: Jimmy Butler showed $1.1M instead of $45.2M. Manually verified all 87.</a:t>
             </a:r>
           </a:p>
@@ -4495,7 +4585,16 @@
               </a:defRPr>
             </a:pPr>
             <a:r>
-              <a:t>74 duplicate player-season rows: NBA API artifact. Same player selected twice on roster. Fixed with dedup.</a:t>
+              <a:rPr dirty="0"/>
+              <a:t>74 duplicate player-season rows: NBA API artifact. Same player selected twice on roster. Fixed with </a:t>
+            </a:r>
+            <a:r>
+              <a:rPr dirty="0" err="1"/>
+              <a:t>dedup</a:t>
+            </a:r>
+            <a:r>
+              <a:rPr dirty="0"/>
+              <a:t>.</a:t>
             </a:r>
           </a:p>
           <a:p>
@@ -4511,6 +4610,7 @@
               </a:defRPr>
             </a:pPr>
             <a:r>
+              <a:rPr dirty="0"/>
               <a:t>Hardcoded cluster labels broke on every data change: Jokic labeled 'Bench Player'. Fixed with dynamic centroid labeling.</a:t>
             </a:r>
           </a:p>
@@ -4527,6 +4627,7 @@
               </a:defRPr>
             </a:pPr>
             <a:r>
+              <a:rPr dirty="0"/>
               <a:t>Non-shooters passed 3PT constraint: FG3% neutralization set Gobert to league avg, making him a 'shooter'. Fixed with IS_SHOOTER flag.</a:t>
             </a:r>
           </a:p>
@@ -4543,6 +4644,7 @@
               </a:defRPr>
             </a:pPr>
             <a:r>
+              <a:rPr dirty="0"/>
               <a:t>Stale archetype name 'Two-Way Guard': optimizer constraint silently matched 0 players. Renamed to 'Versatile Scorer'.</a:t>
             </a:r>
           </a:p>
@@ -4559,6 +4661,7 @@
               </a:defRPr>
             </a:pPr>
             <a:r>
+              <a:rPr dirty="0"/>
               <a:t>Equal PCA weights: LaMelo ranked #4 over Embiid. Fixed with variance-explained weighting.</a:t>
             </a:r>
           </a:p>
@@ -4575,6 +4678,7 @@
               </a:defRPr>
             </a:pPr>
             <a:r>
+              <a:rPr dirty="0"/>
               <a:t>Stale methodology text: dashboard described old approach. Corrected.</a:t>
             </a:r>
           </a:p>
@@ -4590,6 +4694,7 @@
                 <a:latin typeface="Calibri"/>
               </a:defRPr>
             </a:pPr>
+            <a:endParaRPr dirty="0"/>
           </a:p>
           <a:p>
             <a:pPr>
@@ -4604,6 +4709,7 @@
               </a:defRPr>
             </a:pPr>
             <a:r>
+              <a:rPr dirty="0"/>
               <a:t>AUTOMATED VERIFICATION: 175 checks across all pipeline outputs — all passing.</a:t>
             </a:r>
           </a:p>
@@ -4618,7 +4724,7 @@
 </file>
 
 <file path=ppt/slides/slide16.xml><?xml version="1.0" encoding="utf-8"?>
-<p:sld xmlns:a="http://schemas.openxmlformats.org/drawingml/2006/main" xmlns:p="http://schemas.openxmlformats.org/presentationml/2006/main" xmlns:r="http://schemas.openxmlformats.org/officeDocument/2006/relationships">
+<p:sld xmlns:a="http://schemas.openxmlformats.org/drawingml/2006/main" xmlns:r="http://schemas.openxmlformats.org/officeDocument/2006/relationships" xmlns:p="http://schemas.openxmlformats.org/presentationml/2006/main">
   <p:cSld>
     <p:bg>
       <p:bgPr>
@@ -4634,7 +4740,14 @@
         <p:cNvGrpSpPr/>
         <p:nvPr/>
       </p:nvGrpSpPr>
-      <p:grpSpPr/>
+      <p:grpSpPr>
+        <a:xfrm>
+          <a:off x="0" y="0"/>
+          <a:ext cx="0" cy="0"/>
+          <a:chOff x="0" y="0"/>
+          <a:chExt cx="0" cy="0"/>
+        </a:xfrm>
+      </p:grpSpPr>
       <p:sp>
         <p:nvSpPr>
           <p:cNvPr id="2" name="TextBox 1"/>
@@ -4720,6 +4833,7 @@
                 <a:latin typeface="Calibri"/>
               </a:defRPr>
             </a:pPr>
+            <a:endParaRPr/>
           </a:p>
           <a:p>
             <a:pPr>
@@ -4765,6 +4879,7 @@
                 <a:latin typeface="Calibri"/>
               </a:defRPr>
             </a:pPr>
+            <a:endParaRPr/>
           </a:p>
           <a:p>
             <a:pPr>
@@ -4810,6 +4925,7 @@
                 <a:latin typeface="Calibri"/>
               </a:defRPr>
             </a:pPr>
+            <a:endParaRPr/>
           </a:p>
           <a:p>
             <a:pPr>
@@ -4855,6 +4971,7 @@
                 <a:latin typeface="Calibri"/>
               </a:defRPr>
             </a:pPr>
+            <a:endParaRPr/>
           </a:p>
           <a:p>
             <a:pPr>
@@ -4899,7 +5016,7 @@
 </file>
 
 <file path=ppt/slides/slide17.xml><?xml version="1.0" encoding="utf-8"?>
-<p:sld xmlns:a="http://schemas.openxmlformats.org/drawingml/2006/main" xmlns:p="http://schemas.openxmlformats.org/presentationml/2006/main" xmlns:r="http://schemas.openxmlformats.org/officeDocument/2006/relationships">
+<p:sld xmlns:a="http://schemas.openxmlformats.org/drawingml/2006/main" xmlns:r="http://schemas.openxmlformats.org/officeDocument/2006/relationships" xmlns:p="http://schemas.openxmlformats.org/presentationml/2006/main">
   <p:cSld>
     <p:bg>
       <p:bgPr>
@@ -4915,7 +5032,14 @@
         <p:cNvGrpSpPr/>
         <p:nvPr/>
       </p:nvGrpSpPr>
-      <p:grpSpPr/>
+      <p:grpSpPr>
+        <a:xfrm>
+          <a:off x="0" y="0"/>
+          <a:ext cx="0" cy="0"/>
+          <a:chOff x="0" y="0"/>
+          <a:chExt cx="0" cy="0"/>
+        </a:xfrm>
+      </p:grpSpPr>
       <p:sp>
         <p:nvSpPr>
           <p:cNvPr id="2" name="TextBox 1"/>
@@ -5062,6 +5186,7 @@
               <a:t>09_verify_pipeline       175 automated checks — all passing</a:t>
             </a:r>
             <a:br/>
+            <a:endParaRPr/>
           </a:p>
         </p:txBody>
       </p:sp>
@@ -5074,7 +5199,7 @@
 </file>
 
 <file path=ppt/slides/slide18.xml><?xml version="1.0" encoding="utf-8"?>
-<p:sld xmlns:a="http://schemas.openxmlformats.org/drawingml/2006/main" xmlns:p="http://schemas.openxmlformats.org/presentationml/2006/main" xmlns:r="http://schemas.openxmlformats.org/officeDocument/2006/relationships">
+<p:sld xmlns:a="http://schemas.openxmlformats.org/drawingml/2006/main" xmlns:r="http://schemas.openxmlformats.org/officeDocument/2006/relationships" xmlns:p="http://schemas.openxmlformats.org/presentationml/2006/main">
   <p:cSld>
     <p:bg>
       <p:bgPr>
@@ -5090,7 +5215,14 @@
         <p:cNvGrpSpPr/>
         <p:nvPr/>
       </p:nvGrpSpPr>
-      <p:grpSpPr/>
+      <p:grpSpPr>
+        <a:xfrm>
+          <a:off x="0" y="0"/>
+          <a:ext cx="0" cy="0"/>
+          <a:chOff x="0" y="0"/>
+          <a:chExt cx="0" cy="0"/>
+        </a:xfrm>
+      </p:grpSpPr>
       <p:sp>
         <p:nvSpPr>
           <p:cNvPr id="2" name="TextBox 1"/>
@@ -5303,7 +5435,7 @@
 </file>
 
 <file path=ppt/slides/slide19.xml><?xml version="1.0" encoding="utf-8"?>
-<p:sld xmlns:a="http://schemas.openxmlformats.org/drawingml/2006/main" xmlns:p="http://schemas.openxmlformats.org/presentationml/2006/main" xmlns:r="http://schemas.openxmlformats.org/officeDocument/2006/relationships">
+<p:sld xmlns:a="http://schemas.openxmlformats.org/drawingml/2006/main" xmlns:r="http://schemas.openxmlformats.org/officeDocument/2006/relationships" xmlns:p="http://schemas.openxmlformats.org/presentationml/2006/main">
   <p:cSld>
     <p:bg>
       <p:bgPr>
@@ -5319,7 +5451,14 @@
         <p:cNvGrpSpPr/>
         <p:nvPr/>
       </p:nvGrpSpPr>
-      <p:grpSpPr/>
+      <p:grpSpPr>
+        <a:xfrm>
+          <a:off x="0" y="0"/>
+          <a:ext cx="0" cy="0"/>
+          <a:chOff x="0" y="0"/>
+          <a:chExt cx="0" cy="0"/>
+        </a:xfrm>
+      </p:grpSpPr>
       <p:sp>
         <p:nvSpPr>
           <p:cNvPr id="2" name="TextBox 1"/>
@@ -5437,7 +5576,7 @@
 </file>
 
 <file path=ppt/slides/slide2.xml><?xml version="1.0" encoding="utf-8"?>
-<p:sld xmlns:a="http://schemas.openxmlformats.org/drawingml/2006/main" xmlns:p="http://schemas.openxmlformats.org/presentationml/2006/main" xmlns:r="http://schemas.openxmlformats.org/officeDocument/2006/relationships">
+<p:sld xmlns:a="http://schemas.openxmlformats.org/drawingml/2006/main" xmlns:r="http://schemas.openxmlformats.org/officeDocument/2006/relationships" xmlns:p="http://schemas.openxmlformats.org/presentationml/2006/main">
   <p:cSld>
     <p:bg>
       <p:bgPr>
@@ -5453,7 +5592,14 @@
         <p:cNvGrpSpPr/>
         <p:nvPr/>
       </p:nvGrpSpPr>
-      <p:grpSpPr/>
+      <p:grpSpPr>
+        <a:xfrm>
+          <a:off x="0" y="0"/>
+          <a:ext cx="0" cy="0"/>
+          <a:chOff x="0" y="0"/>
+          <a:chExt cx="0" cy="0"/>
+        </a:xfrm>
+      </p:grpSpPr>
       <p:sp>
         <p:nvSpPr>
           <p:cNvPr id="2" name="TextBox 1"/>
@@ -5587,6 +5733,7 @@
                 <a:latin typeface="Calibri"/>
               </a:defRPr>
             </a:pPr>
+            <a:endParaRPr/>
           </a:p>
           <a:p>
             <a:pPr>
@@ -5631,7 +5778,7 @@
 </file>
 
 <file path=ppt/slides/slide3.xml><?xml version="1.0" encoding="utf-8"?>
-<p:sld xmlns:a="http://schemas.openxmlformats.org/drawingml/2006/main" xmlns:p="http://schemas.openxmlformats.org/presentationml/2006/main" xmlns:r="http://schemas.openxmlformats.org/officeDocument/2006/relationships">
+<p:sld xmlns:a="http://schemas.openxmlformats.org/drawingml/2006/main" xmlns:r="http://schemas.openxmlformats.org/officeDocument/2006/relationships" xmlns:p="http://schemas.openxmlformats.org/presentationml/2006/main">
   <p:cSld>
     <p:bg>
       <p:bgPr>
@@ -5647,7 +5794,14 @@
         <p:cNvGrpSpPr/>
         <p:nvPr/>
       </p:nvGrpSpPr>
-      <p:grpSpPr/>
+      <p:grpSpPr>
+        <a:xfrm>
+          <a:off x="0" y="0"/>
+          <a:ext cx="0" cy="0"/>
+          <a:chOff x="0" y="0"/>
+          <a:chExt cx="0" cy="0"/>
+        </a:xfrm>
+      </p:grpSpPr>
       <p:sp>
         <p:nvSpPr>
           <p:cNvPr id="2" name="TextBox 1"/>
@@ -5828,7 +5982,7 @@
 </file>
 
 <file path=ppt/slides/slide4.xml><?xml version="1.0" encoding="utf-8"?>
-<p:sld xmlns:a="http://schemas.openxmlformats.org/drawingml/2006/main" xmlns:p="http://schemas.openxmlformats.org/presentationml/2006/main" xmlns:r="http://schemas.openxmlformats.org/officeDocument/2006/relationships">
+<p:sld xmlns:a="http://schemas.openxmlformats.org/drawingml/2006/main" xmlns:r="http://schemas.openxmlformats.org/officeDocument/2006/relationships" xmlns:p="http://schemas.openxmlformats.org/presentationml/2006/main">
   <p:cSld>
     <p:bg>
       <p:bgPr>
@@ -5844,7 +5998,14 @@
         <p:cNvGrpSpPr/>
         <p:nvPr/>
       </p:nvGrpSpPr>
-      <p:grpSpPr/>
+      <p:grpSpPr>
+        <a:xfrm>
+          <a:off x="0" y="0"/>
+          <a:ext cx="0" cy="0"/>
+          <a:chOff x="0" y="0"/>
+          <a:chExt cx="0" cy="0"/>
+        </a:xfrm>
+      </p:grpSpPr>
       <p:sp>
         <p:nvSpPr>
           <p:cNvPr id="2" name="TextBox 1"/>
@@ -6009,7 +6170,7 @@
 </file>
 
 <file path=ppt/slides/slide5.xml><?xml version="1.0" encoding="utf-8"?>
-<p:sld xmlns:a="http://schemas.openxmlformats.org/drawingml/2006/main" xmlns:p="http://schemas.openxmlformats.org/presentationml/2006/main" xmlns:r="http://schemas.openxmlformats.org/officeDocument/2006/relationships">
+<p:sld xmlns:a="http://schemas.openxmlformats.org/drawingml/2006/main" xmlns:r="http://schemas.openxmlformats.org/officeDocument/2006/relationships" xmlns:p="http://schemas.openxmlformats.org/presentationml/2006/main">
   <p:cSld>
     <p:bg>
       <p:bgPr>
@@ -6025,7 +6186,14 @@
         <p:cNvGrpSpPr/>
         <p:nvPr/>
       </p:nvGrpSpPr>
-      <p:grpSpPr/>
+      <p:grpSpPr>
+        <a:xfrm>
+          <a:off x="0" y="0"/>
+          <a:ext cx="0" cy="0"/>
+          <a:chOff x="0" y="0"/>
+          <a:chExt cx="0" cy="0"/>
+        </a:xfrm>
+      </p:grpSpPr>
       <p:sp>
         <p:nvSpPr>
           <p:cNvPr id="2" name="TextBox 1"/>
@@ -6191,6 +6359,7 @@
                 <a:latin typeface="Calibri"/>
               </a:defRPr>
             </a:pPr>
+            <a:endParaRPr/>
           </a:p>
           <a:p>
             <a:pPr>
@@ -6219,7 +6388,7 @@
 </file>
 
 <file path=ppt/slides/slide6.xml><?xml version="1.0" encoding="utf-8"?>
-<p:sld xmlns:a="http://schemas.openxmlformats.org/drawingml/2006/main" xmlns:p="http://schemas.openxmlformats.org/presentationml/2006/main" xmlns:r="http://schemas.openxmlformats.org/officeDocument/2006/relationships">
+<p:sld xmlns:a="http://schemas.openxmlformats.org/drawingml/2006/main" xmlns:r="http://schemas.openxmlformats.org/officeDocument/2006/relationships" xmlns:p="http://schemas.openxmlformats.org/presentationml/2006/main">
   <p:cSld>
     <p:bg>
       <p:bgPr>
@@ -6235,7 +6404,14 @@
         <p:cNvGrpSpPr/>
         <p:nvPr/>
       </p:nvGrpSpPr>
-      <p:grpSpPr/>
+      <p:grpSpPr>
+        <a:xfrm>
+          <a:off x="0" y="0"/>
+          <a:ext cx="0" cy="0"/>
+          <a:chOff x="0" y="0"/>
+          <a:chExt cx="0" cy="0"/>
+        </a:xfrm>
+      </p:grpSpPr>
       <p:sp>
         <p:nvSpPr>
           <p:cNvPr id="2" name="TextBox 1"/>
@@ -6341,7 +6517,7 @@
 </file>
 
 <file path=ppt/slides/slide7.xml><?xml version="1.0" encoding="utf-8"?>
-<p:sld xmlns:a="http://schemas.openxmlformats.org/drawingml/2006/main" xmlns:p="http://schemas.openxmlformats.org/presentationml/2006/main" xmlns:r="http://schemas.openxmlformats.org/officeDocument/2006/relationships">
+<p:sld xmlns:a="http://schemas.openxmlformats.org/drawingml/2006/main" xmlns:r="http://schemas.openxmlformats.org/officeDocument/2006/relationships" xmlns:p="http://schemas.openxmlformats.org/presentationml/2006/main">
   <p:cSld>
     <p:bg>
       <p:bgPr>
@@ -6357,7 +6533,14 @@
         <p:cNvGrpSpPr/>
         <p:nvPr/>
       </p:nvGrpSpPr>
-      <p:grpSpPr/>
+      <p:grpSpPr>
+        <a:xfrm>
+          <a:off x="0" y="0"/>
+          <a:ext cx="0" cy="0"/>
+          <a:chOff x="0" y="0"/>
+          <a:chExt cx="0" cy="0"/>
+        </a:xfrm>
+      </p:grpSpPr>
       <p:sp>
         <p:nvSpPr>
           <p:cNvPr id="2" name="TextBox 1"/>
@@ -6506,7 +6689,7 @@
 </file>
 
 <file path=ppt/slides/slide8.xml><?xml version="1.0" encoding="utf-8"?>
-<p:sld xmlns:a="http://schemas.openxmlformats.org/drawingml/2006/main" xmlns:p="http://schemas.openxmlformats.org/presentationml/2006/main" xmlns:r="http://schemas.openxmlformats.org/officeDocument/2006/relationships">
+<p:sld xmlns:a="http://schemas.openxmlformats.org/drawingml/2006/main" xmlns:r="http://schemas.openxmlformats.org/officeDocument/2006/relationships" xmlns:p="http://schemas.openxmlformats.org/presentationml/2006/main">
   <p:cSld>
     <p:bg>
       <p:bgPr>
@@ -6522,7 +6705,14 @@
         <p:cNvGrpSpPr/>
         <p:nvPr/>
       </p:nvGrpSpPr>
-      <p:grpSpPr/>
+      <p:grpSpPr>
+        <a:xfrm>
+          <a:off x="0" y="0"/>
+          <a:ext cx="0" cy="0"/>
+          <a:chOff x="0" y="0"/>
+          <a:chExt cx="0" cy="0"/>
+        </a:xfrm>
+      </p:grpSpPr>
       <p:sp>
         <p:nvSpPr>
           <p:cNvPr id="2" name="TextBox 1"/>
@@ -6590,85 +6780,86 @@
               </a:defRPr>
             </a:pPr>
             <a:r>
-              <a:t> 1. Nikola Jokić                 95.9</a:t>
-            </a:r>
-            <a:br/>
-            <a:r>
-              <a:t> 2. Shai Gilgeous-Alexander      91.4</a:t>
-            </a:r>
-            <a:br/>
-            <a:r>
-              <a:t> 3. Luka Dončić                  90.4</a:t>
-            </a:r>
-            <a:br/>
-            <a:r>
-              <a:t> 4. Joel Embiid                  86.6</a:t>
-            </a:r>
-            <a:br/>
-            <a:r>
-              <a:t> 5. LaMelo Ball                  84.0</a:t>
-            </a:r>
-            <a:br/>
-            <a:r>
-              <a:t> 6. Giannis Antetokounmpo        83.1</a:t>
-            </a:r>
-            <a:br/>
-            <a:r>
-              <a:t> 7. Donovan Mitchell             82.0</a:t>
-            </a:r>
-            <a:br/>
-            <a:r>
-              <a:t> 8. De'Aaron Fox                 81.7</a:t>
-            </a:r>
-            <a:br/>
-            <a:r>
-              <a:t> 9. Tyrese Haliburton            81.0</a:t>
-            </a:r>
-            <a:br/>
-            <a:r>
-              <a:t>10. Jalen Brunson                79.9</a:t>
-            </a:r>
-            <a:br/>
-            <a:r>
-              <a:t>11. LeBron James                 79.2</a:t>
-            </a:r>
-            <a:br/>
-            <a:r>
-              <a:t>12. Marcus Smart                 78.1</a:t>
-            </a:r>
-            <a:br/>
-            <a:r>
-              <a:t>13. Paul George                  77.6</a:t>
-            </a:r>
-            <a:br/>
-            <a:r>
-              <a:t>14. Kawhi Leonard                75.9</a:t>
-            </a:r>
-            <a:br/>
-            <a:r>
-              <a:t>15. Trae Young                   75.1</a:t>
-            </a:r>
-            <a:br/>
-            <a:r>
-              <a:t>16. Damian Lillard               74.6</a:t>
-            </a:r>
-            <a:br/>
-            <a:r>
-              <a:t>17. Kyrie Irving                 72.0</a:t>
-            </a:r>
-            <a:br/>
-            <a:r>
-              <a:t>18. Scottie Barnes               71.8</a:t>
-            </a:r>
-            <a:br/>
-            <a:r>
-              <a:t>19. Cade Cunningham              71.2</a:t>
-            </a:r>
-            <a:br/>
-            <a:r>
-              <a:t>20. Devin Booker                 70.7</a:t>
-            </a:r>
-            <a:br/>
+              <a:t> 1. Nikola Jokić                 96.3</a:t>
+            </a:r>
+            <a:br/>
+            <a:r>
+              <a:t> 2. Shai Gilgeous-Alexander      89.0</a:t>
+            </a:r>
+            <a:br/>
+            <a:r>
+              <a:t> 3. Luka Dončić                  87.5</a:t>
+            </a:r>
+            <a:br/>
+            <a:r>
+              <a:t> 4. Giannis Antetokounmpo        81.5</a:t>
+            </a:r>
+            <a:br/>
+            <a:r>
+              <a:t> 5. Joel Embiid                  79.8</a:t>
+            </a:r>
+            <a:br/>
+            <a:r>
+              <a:t> 6. Tyrese Haliburton            78.2</a:t>
+            </a:r>
+            <a:br/>
+            <a:r>
+              <a:t> 7. De'Aaron Fox                 77.3</a:t>
+            </a:r>
+            <a:br/>
+            <a:r>
+              <a:t> 8. Donovan Mitchell             76.7</a:t>
+            </a:r>
+            <a:br/>
+            <a:r>
+              <a:t> 9. Jalen Brunson                76.6</a:t>
+            </a:r>
+            <a:br/>
+            <a:r>
+              <a:t>10. LaMelo Ball                  75.0</a:t>
+            </a:r>
+            <a:br/>
+            <a:r>
+              <a:t>11. LeBron James                 73.6</a:t>
+            </a:r>
+            <a:br/>
+            <a:r>
+              <a:t>12. Damian Lillard               72.1</a:t>
+            </a:r>
+            <a:br/>
+            <a:r>
+              <a:t>13. Paul George                  71.2</a:t>
+            </a:r>
+            <a:br/>
+            <a:r>
+              <a:t>14. Trae Young                   69.8</a:t>
+            </a:r>
+            <a:br/>
+            <a:r>
+              <a:t>15. Kawhi Leonard                68.7</a:t>
+            </a:r>
+            <a:br/>
+            <a:r>
+              <a:t>16. Marcus Smart                 68.6</a:t>
+            </a:r>
+            <a:br/>
+            <a:r>
+              <a:t>17. Scottie Barnes               68.2</a:t>
+            </a:r>
+            <a:br/>
+            <a:r>
+              <a:t>18. Cade Cunningham              67.8</a:t>
+            </a:r>
+            <a:br/>
+            <a:r>
+              <a:t>19. Devin Booker                 66.9</a:t>
+            </a:r>
+            <a:br/>
+            <a:r>
+              <a:t>20. Jusuf Nurkić                 66.8</a:t>
+            </a:r>
+            <a:br/>
+            <a:endParaRPr/>
           </a:p>
         </p:txBody>
       </p:sp>
@@ -6705,7 +6896,7 @@
 </file>
 
 <file path=ppt/slides/slide9.xml><?xml version="1.0" encoding="utf-8"?>
-<p:sld xmlns:a="http://schemas.openxmlformats.org/drawingml/2006/main" xmlns:p="http://schemas.openxmlformats.org/presentationml/2006/main" xmlns:r="http://schemas.openxmlformats.org/officeDocument/2006/relationships">
+<p:sld xmlns:a="http://schemas.openxmlformats.org/drawingml/2006/main" xmlns:r="http://schemas.openxmlformats.org/officeDocument/2006/relationships" xmlns:p="http://schemas.openxmlformats.org/presentationml/2006/main">
   <p:cSld>
     <p:bg>
       <p:bgPr>
@@ -6721,7 +6912,14 @@
         <p:cNvGrpSpPr/>
         <p:nvPr/>
       </p:nvGrpSpPr>
-      <p:grpSpPr/>
+      <p:grpSpPr>
+        <a:xfrm>
+          <a:off x="0" y="0"/>
+          <a:ext cx="0" cy="0"/>
+          <a:chOff x="0" y="0"/>
+          <a:chExt cx="0" cy="0"/>
+        </a:xfrm>
+      </p:grpSpPr>
       <p:sp>
         <p:nvSpPr>
           <p:cNvPr id="2" name="TextBox 1"/>
@@ -6820,8 +7018,8 @@
         </p:blipFill>
         <p:spPr>
           <a:xfrm>
-            <a:off x="5760720" y="365760"/>
-            <a:ext cx="5943600" cy="3017520"/>
+            <a:off x="5760719" y="914400"/>
+            <a:ext cx="5943601" cy="2812016"/>
           </a:xfrm>
           <a:prstGeom prst="rect">
             <a:avLst/>
@@ -6844,8 +7042,8 @@
         </p:blipFill>
         <p:spPr>
           <a:xfrm>
-            <a:off x="5760720" y="3474720"/>
-            <a:ext cx="5943600" cy="3200400"/>
+            <a:off x="5760720" y="3726416"/>
+            <a:ext cx="5943600" cy="3131584"/>
           </a:xfrm>
           <a:prstGeom prst="rect">
             <a:avLst/>

</xml_diff>